<commit_message>
Test automation Fix documentation
</commit_message>
<xml_diff>
--- a/docs/scripts/docs/automation_kb_update_presentation.pptx
+++ b/docs/scripts/docs/automation_kb_update_presentation.pptx
@@ -4304,6 +4304,14 @@
             </a:pPr>
             <a:r>
               <a:t>mode: Full, Prepare, Upload</a:t>
+            </a:r>
+          </a:p>
+          <a:p>
+            <a:pPr>
+              <a:defRPr sz="2200"/>
+            </a:pPr>
+            <a:r>
+              <a:t>existing_datasource_mode: Replace or Add</a:t>
             </a:r>
           </a:p>
           <a:p>

</xml_diff>